<commit_message>
updating ppt and class agenda for class_20
</commit_message>
<xml_diff>
--- a/docs/lectures/in-class_activities/class_20.pptx
+++ b/docs/lectures/in-class_activities/class_20.pptx
@@ -5,19 +5,17 @@
     <p:sldMasterId id="2147483648" r:id="rId1"/>
   </p:sldMasterIdLst>
   <p:notesMasterIdLst>
-    <p:notesMasterId r:id="rId12"/>
+    <p:notesMasterId r:id="rId10"/>
   </p:notesMasterIdLst>
   <p:sldIdLst>
     <p:sldId id="480" r:id="rId2"/>
     <p:sldId id="723" r:id="rId3"/>
-    <p:sldId id="1554" r:id="rId4"/>
-    <p:sldId id="1572" r:id="rId5"/>
-    <p:sldId id="1581" r:id="rId6"/>
-    <p:sldId id="1582" r:id="rId7"/>
-    <p:sldId id="1583" r:id="rId8"/>
-    <p:sldId id="1584" r:id="rId9"/>
-    <p:sldId id="1585" r:id="rId10"/>
-    <p:sldId id="1580" r:id="rId11"/>
+    <p:sldId id="1572" r:id="rId4"/>
+    <p:sldId id="1581" r:id="rId5"/>
+    <p:sldId id="1582" r:id="rId6"/>
+    <p:sldId id="1584" r:id="rId7"/>
+    <p:sldId id="1585" r:id="rId8"/>
+    <p:sldId id="1580" r:id="rId9"/>
   </p:sldIdLst>
   <p:sldSz cx="12192000" cy="6858000"/>
   <p:notesSz cx="6858000" cy="9144000"/>
@@ -206,7 +204,7 @@
           <a:p>
             <a:fld id="{6AC7DB66-C6D6-B24E-B345-FA3772C924EA}" type="datetimeFigureOut">
               <a:rPr lang="en-US" smtClean="0"/>
-              <a:t>11/17/21</a:t>
+              <a:t>11/17/25</a:t>
             </a:fld>
             <a:endParaRPr lang="en-US"/>
           </a:p>
@@ -557,90 +555,6 @@
 </p:notes>
 </file>
 
-<file path=ppt/notesSlides/notesSlide10.xml><?xml version="1.0" encoding="utf-8"?>
-<p:notes xmlns:a="http://schemas.openxmlformats.org/drawingml/2006/main" xmlns:r="http://schemas.openxmlformats.org/officeDocument/2006/relationships" xmlns:p="http://schemas.openxmlformats.org/presentationml/2006/main">
-  <p:cSld>
-    <p:spTree>
-      <p:nvGrpSpPr>
-        <p:cNvPr id="1" name=""/>
-        <p:cNvGrpSpPr/>
-        <p:nvPr/>
-      </p:nvGrpSpPr>
-      <p:grpSpPr>
-        <a:xfrm>
-          <a:off x="0" y="0"/>
-          <a:ext cx="0" cy="0"/>
-          <a:chOff x="0" y="0"/>
-          <a:chExt cx="0" cy="0"/>
-        </a:xfrm>
-      </p:grpSpPr>
-      <p:sp>
-        <p:nvSpPr>
-          <p:cNvPr id="2" name="Slide Image Placeholder 1"/>
-          <p:cNvSpPr>
-            <a:spLocks noGrp="1" noRot="1" noChangeAspect="1"/>
-          </p:cNvSpPr>
-          <p:nvPr>
-            <p:ph type="sldImg"/>
-          </p:nvPr>
-        </p:nvSpPr>
-        <p:spPr/>
-      </p:sp>
-      <p:sp>
-        <p:nvSpPr>
-          <p:cNvPr id="3" name="Notes Placeholder 2"/>
-          <p:cNvSpPr>
-            <a:spLocks noGrp="1"/>
-          </p:cNvSpPr>
-          <p:nvPr>
-            <p:ph type="body" idx="1"/>
-          </p:nvPr>
-        </p:nvSpPr>
-        <p:spPr/>
-        <p:txBody>
-          <a:bodyPr/>
-          <a:lstStyle/>
-          <a:p>
-            <a:endParaRPr lang="en-US"/>
-          </a:p>
-        </p:txBody>
-      </p:sp>
-      <p:sp>
-        <p:nvSpPr>
-          <p:cNvPr id="4" name="Slide Number Placeholder 3"/>
-          <p:cNvSpPr>
-            <a:spLocks noGrp="1"/>
-          </p:cNvSpPr>
-          <p:nvPr>
-            <p:ph type="sldNum" sz="quarter" idx="5"/>
-          </p:nvPr>
-        </p:nvSpPr>
-        <p:spPr/>
-        <p:txBody>
-          <a:bodyPr/>
-          <a:lstStyle/>
-          <a:p>
-            <a:fld id="{4218707C-A528-5347-B512-111D9A72273A}" type="slidenum">
-              <a:rPr lang="en-US" smtClean="0"/>
-              <a:t>10</a:t>
-            </a:fld>
-            <a:endParaRPr lang="en-US"/>
-          </a:p>
-        </p:txBody>
-      </p:sp>
-    </p:spTree>
-    <p:extLst>
-      <p:ext uri="{BB962C8B-B14F-4D97-AF65-F5344CB8AC3E}">
-        <p14:creationId xmlns:p14="http://schemas.microsoft.com/office/powerpoint/2010/main" val="334769319"/>
-      </p:ext>
-    </p:extLst>
-  </p:cSld>
-  <p:clrMapOvr>
-    <a:masterClrMapping/>
-  </p:clrMapOvr>
-</p:notes>
-</file>
-
 <file path=ppt/notesSlides/notesSlide2.xml><?xml version="1.0" encoding="utf-8"?>
 <p:notes xmlns:a="http://schemas.openxmlformats.org/drawingml/2006/main" xmlns:r="http://schemas.openxmlformats.org/officeDocument/2006/relationships" xmlns:p="http://schemas.openxmlformats.org/presentationml/2006/main">
   <p:cSld>
@@ -769,24 +683,7 @@
           <a:bodyPr/>
           <a:lstStyle/>
           <a:p>
-            <a:endParaRPr lang="en-US" dirty="0"/>
-          </a:p>
-          <a:p>
-            <a:r>
-              <a:rPr lang="en-US" dirty="0"/>
-              <a:t>Changes in any attribute of a population over time. </a:t>
-            </a:r>
-          </a:p>
-          <a:p>
-            <a:r>
-              <a:rPr lang="en-US" dirty="0"/>
-              <a:t>Evolutionary</a:t>
-            </a:r>
-            <a:r>
-              <a:rPr lang="en-US" baseline="0" dirty="0"/>
-              <a:t> change leads to adaptation and must involve a change in the frequency of individual genes in a population from generation to generation.</a:t>
-            </a:r>
-            <a:endParaRPr lang="en-US" dirty="0"/>
+            <a:endParaRPr lang="en-US"/>
           </a:p>
         </p:txBody>
       </p:sp>
@@ -797,22 +694,16 @@
             <a:spLocks noGrp="1"/>
           </p:cNvSpPr>
           <p:nvPr>
-            <p:ph type="sldNum" sz="quarter" idx="10"/>
-          </p:nvPr>
-        </p:nvSpPr>
-        <p:spPr/>
-        <p:txBody>
-          <a:bodyPr/>
-          <a:lstStyle/>
-          <a:p>
-            <a:pPr>
-              <a:defRPr/>
-            </a:pPr>
-            <a:fld id="{217FB9E2-7C0C-AB45-B0B4-06C6B1BD2B82}" type="slidenum">
+            <p:ph type="sldNum" sz="quarter" idx="5"/>
+          </p:nvPr>
+        </p:nvSpPr>
+        <p:spPr/>
+        <p:txBody>
+          <a:bodyPr/>
+          <a:lstStyle/>
+          <a:p>
+            <a:fld id="{4218707C-A528-5347-B512-111D9A72273A}" type="slidenum">
               <a:rPr lang="en-US" smtClean="0"/>
-              <a:pPr>
-                <a:defRPr/>
-              </a:pPr>
               <a:t>3</a:t>
             </a:fld>
             <a:endParaRPr lang="en-US"/>
@@ -822,7 +713,7 @@
     </p:spTree>
     <p:extLst>
       <p:ext uri="{BB962C8B-B14F-4D97-AF65-F5344CB8AC3E}">
-        <p14:creationId xmlns:p14="http://schemas.microsoft.com/office/powerpoint/2010/main" val="2879652891"/>
+        <p14:creationId xmlns:p14="http://schemas.microsoft.com/office/powerpoint/2010/main" val="3481837843"/>
       </p:ext>
     </p:extLst>
   </p:cSld>
@@ -876,7 +767,16 @@
           <a:bodyPr/>
           <a:lstStyle/>
           <a:p>
-            <a:endParaRPr lang="en-US"/>
+            <a:r>
+              <a:rPr lang="en-US"/>
+              <a:t>There are three forms of African sleeping sickness. Which do you think would be the EASIEST to control?</a:t>
+            </a:r>
+          </a:p>
+          <a:p>
+            <a:r>
+              <a:rPr lang="en-US"/>
+              <a:t>https://www.polleverywhere.com/multiple_choice_polls/Dt6RIWtlQrleiczdoI5yP?flow=Default&amp;onscreen=persist</a:t>
+            </a:r>
           </a:p>
         </p:txBody>
       </p:sp>
@@ -906,7 +806,7 @@
     </p:spTree>
     <p:extLst>
       <p:ext uri="{BB962C8B-B14F-4D97-AF65-F5344CB8AC3E}">
-        <p14:creationId xmlns:p14="http://schemas.microsoft.com/office/powerpoint/2010/main" val="3481837843"/>
+        <p14:creationId xmlns:p14="http://schemas.microsoft.com/office/powerpoint/2010/main" val="1986591616"/>
       </p:ext>
     </p:extLst>
   </p:cSld>
@@ -962,13 +862,13 @@
           <a:p>
             <a:r>
               <a:rPr lang="en-US"/>
-              <a:t>There are three forms of African sleeping sickness. Which do you think would be the EASIEST to control?</a:t>
-            </a:r>
-          </a:p>
-          <a:p>
-            <a:r>
-              <a:rPr lang="en-US"/>
-              <a:t>https://www.polleverywhere.com/multiple_choice_polls/Dt6RIWtlQrleiczdoI5yP?flow=Default&amp;onscreen=persist</a:t>
+              <a:t>There are three forms of African sleeping sickness. Which do you think would be the most MOST DIFFICULT to control?</a:t>
+            </a:r>
+          </a:p>
+          <a:p>
+            <a:r>
+              <a:rPr lang="en-US"/>
+              <a:t>https://www.polleverywhere.com/multiple_choice_polls/69EoUkLjVA4LYkhBHxI8Y?flow=Default&amp;onscreen=persist</a:t>
             </a:r>
           </a:p>
         </p:txBody>
@@ -999,7 +899,7 @@
     </p:spTree>
     <p:extLst>
       <p:ext uri="{BB962C8B-B14F-4D97-AF65-F5344CB8AC3E}">
-        <p14:creationId xmlns:p14="http://schemas.microsoft.com/office/powerpoint/2010/main" val="1986591616"/>
+        <p14:creationId xmlns:p14="http://schemas.microsoft.com/office/powerpoint/2010/main" val="3591303418"/>
       </p:ext>
     </p:extLst>
   </p:cSld>
@@ -1053,16 +953,7 @@
           <a:bodyPr/>
           <a:lstStyle/>
           <a:p>
-            <a:r>
-              <a:rPr lang="en-US"/>
-              <a:t>There are three forms of African sleeping sickness. Which do you think would be the most MOST DIFFICULT to control?</a:t>
-            </a:r>
-          </a:p>
-          <a:p>
-            <a:r>
-              <a:rPr lang="en-US"/>
-              <a:t>https://www.polleverywhere.com/multiple_choice_polls/69EoUkLjVA4LYkhBHxI8Y?flow=Default&amp;onscreen=persist</a:t>
-            </a:r>
+            <a:endParaRPr lang="en-US"/>
           </a:p>
         </p:txBody>
       </p:sp>
@@ -1092,7 +983,7 @@
     </p:spTree>
     <p:extLst>
       <p:ext uri="{BB962C8B-B14F-4D97-AF65-F5344CB8AC3E}">
-        <p14:creationId xmlns:p14="http://schemas.microsoft.com/office/powerpoint/2010/main" val="3591303418"/>
+        <p14:creationId xmlns:p14="http://schemas.microsoft.com/office/powerpoint/2010/main" val="2677816062"/>
       </p:ext>
     </p:extLst>
   </p:cSld>
@@ -1146,24 +1037,16 @@
           <a:bodyPr/>
           <a:lstStyle/>
           <a:p>
-            <a:endParaRPr lang="en-US" dirty="0"/>
-          </a:p>
-          <a:p>
-            <a:r>
-              <a:rPr lang="en-US" dirty="0"/>
-              <a:t>Changes in any attribute of a population over time. </a:t>
-            </a:r>
-          </a:p>
-          <a:p>
-            <a:r>
-              <a:rPr lang="en-US" dirty="0"/>
-              <a:t>Evolutionary</a:t>
-            </a:r>
-            <a:r>
-              <a:rPr lang="en-US" baseline="0" dirty="0"/>
-              <a:t> change leads to adaptation and must involve a change in the frequency of individual genes in a population from generation to generation.</a:t>
-            </a:r>
-            <a:endParaRPr lang="en-US" dirty="0"/>
+            <a:r>
+              <a:rPr lang="en-US"/>
+              <a:t>In what kind of habitats would you expect to find the greatest burden of leishmaniasis?</a:t>
+            </a:r>
+          </a:p>
+          <a:p>
+            <a:r>
+              <a:rPr lang="en-US"/>
+              <a:t>https://www.polleverywhere.com/free_text_polls/K7ttNAL6NCk55tvf0BzKW</a:t>
+            </a:r>
           </a:p>
         </p:txBody>
       </p:sp>
@@ -1174,22 +1057,16 @@
             <a:spLocks noGrp="1"/>
           </p:cNvSpPr>
           <p:nvPr>
-            <p:ph type="sldNum" sz="quarter" idx="10"/>
-          </p:nvPr>
-        </p:nvSpPr>
-        <p:spPr/>
-        <p:txBody>
-          <a:bodyPr/>
-          <a:lstStyle/>
-          <a:p>
-            <a:pPr>
-              <a:defRPr/>
-            </a:pPr>
-            <a:fld id="{217FB9E2-7C0C-AB45-B0B4-06C6B1BD2B82}" type="slidenum">
+            <p:ph type="sldNum" sz="quarter" idx="5"/>
+          </p:nvPr>
+        </p:nvSpPr>
+        <p:spPr/>
+        <p:txBody>
+          <a:bodyPr/>
+          <a:lstStyle/>
+          <a:p>
+            <a:fld id="{4218707C-A528-5347-B512-111D9A72273A}" type="slidenum">
               <a:rPr lang="en-US" smtClean="0"/>
-              <a:pPr>
-                <a:defRPr/>
-              </a:pPr>
               <a:t>7</a:t>
             </a:fld>
             <a:endParaRPr lang="en-US"/>
@@ -1199,7 +1076,7 @@
     </p:spTree>
     <p:extLst>
       <p:ext uri="{BB962C8B-B14F-4D97-AF65-F5344CB8AC3E}">
-        <p14:creationId xmlns:p14="http://schemas.microsoft.com/office/powerpoint/2010/main" val="1570183551"/>
+        <p14:creationId xmlns:p14="http://schemas.microsoft.com/office/powerpoint/2010/main" val="3753268355"/>
       </p:ext>
     </p:extLst>
   </p:cSld>
@@ -1283,100 +1160,7 @@
     </p:spTree>
     <p:extLst>
       <p:ext uri="{BB962C8B-B14F-4D97-AF65-F5344CB8AC3E}">
-        <p14:creationId xmlns:p14="http://schemas.microsoft.com/office/powerpoint/2010/main" val="2677816062"/>
-      </p:ext>
-    </p:extLst>
-  </p:cSld>
-  <p:clrMapOvr>
-    <a:masterClrMapping/>
-  </p:clrMapOvr>
-</p:notes>
-</file>
-
-<file path=ppt/notesSlides/notesSlide9.xml><?xml version="1.0" encoding="utf-8"?>
-<p:notes xmlns:a="http://schemas.openxmlformats.org/drawingml/2006/main" xmlns:r="http://schemas.openxmlformats.org/officeDocument/2006/relationships" xmlns:p="http://schemas.openxmlformats.org/presentationml/2006/main">
-  <p:cSld>
-    <p:spTree>
-      <p:nvGrpSpPr>
-        <p:cNvPr id="1" name=""/>
-        <p:cNvGrpSpPr/>
-        <p:nvPr/>
-      </p:nvGrpSpPr>
-      <p:grpSpPr>
-        <a:xfrm>
-          <a:off x="0" y="0"/>
-          <a:ext cx="0" cy="0"/>
-          <a:chOff x="0" y="0"/>
-          <a:chExt cx="0" cy="0"/>
-        </a:xfrm>
-      </p:grpSpPr>
-      <p:sp>
-        <p:nvSpPr>
-          <p:cNvPr id="2" name="Slide Image Placeholder 1"/>
-          <p:cNvSpPr>
-            <a:spLocks noGrp="1" noRot="1" noChangeAspect="1"/>
-          </p:cNvSpPr>
-          <p:nvPr>
-            <p:ph type="sldImg"/>
-          </p:nvPr>
-        </p:nvSpPr>
-        <p:spPr/>
-      </p:sp>
-      <p:sp>
-        <p:nvSpPr>
-          <p:cNvPr id="3" name="Notes Placeholder 2"/>
-          <p:cNvSpPr>
-            <a:spLocks noGrp="1"/>
-          </p:cNvSpPr>
-          <p:nvPr>
-            <p:ph type="body" idx="1"/>
-          </p:nvPr>
-        </p:nvSpPr>
-        <p:spPr/>
-        <p:txBody>
-          <a:bodyPr/>
-          <a:lstStyle/>
-          <a:p>
-            <a:r>
-              <a:rPr lang="en-US"/>
-              <a:t>In what kind of habitats would you expect to find the greatest burden of leishmaniasis?</a:t>
-            </a:r>
-          </a:p>
-          <a:p>
-            <a:r>
-              <a:rPr lang="en-US"/>
-              <a:t>https://www.polleverywhere.com/free_text_polls/K7ttNAL6NCk55tvf0BzKW</a:t>
-            </a:r>
-          </a:p>
-        </p:txBody>
-      </p:sp>
-      <p:sp>
-        <p:nvSpPr>
-          <p:cNvPr id="4" name="Slide Number Placeholder 3"/>
-          <p:cNvSpPr>
-            <a:spLocks noGrp="1"/>
-          </p:cNvSpPr>
-          <p:nvPr>
-            <p:ph type="sldNum" sz="quarter" idx="5"/>
-          </p:nvPr>
-        </p:nvSpPr>
-        <p:spPr/>
-        <p:txBody>
-          <a:bodyPr/>
-          <a:lstStyle/>
-          <a:p>
-            <a:fld id="{4218707C-A528-5347-B512-111D9A72273A}" type="slidenum">
-              <a:rPr lang="en-US" smtClean="0"/>
-              <a:t>9</a:t>
-            </a:fld>
-            <a:endParaRPr lang="en-US"/>
-          </a:p>
-        </p:txBody>
-      </p:sp>
-    </p:spTree>
-    <p:extLst>
-      <p:ext uri="{BB962C8B-B14F-4D97-AF65-F5344CB8AC3E}">
-        <p14:creationId xmlns:p14="http://schemas.microsoft.com/office/powerpoint/2010/main" val="3753268355"/>
+        <p14:creationId xmlns:p14="http://schemas.microsoft.com/office/powerpoint/2010/main" val="334769319"/>
       </p:ext>
     </p:extLst>
   </p:cSld>
@@ -1533,7 +1317,7 @@
           <a:p>
             <a:fld id="{21DDE3A9-9D48-7D40-AF95-520AE186EA5D}" type="datetimeFigureOut">
               <a:rPr lang="en-US" smtClean="0"/>
-              <a:t>11/17/21</a:t>
+              <a:t>11/17/25</a:t>
             </a:fld>
             <a:endParaRPr lang="en-US"/>
           </a:p>
@@ -1731,7 +1515,7 @@
           <a:p>
             <a:fld id="{21DDE3A9-9D48-7D40-AF95-520AE186EA5D}" type="datetimeFigureOut">
               <a:rPr lang="en-US" smtClean="0"/>
-              <a:t>11/17/21</a:t>
+              <a:t>11/17/25</a:t>
             </a:fld>
             <a:endParaRPr lang="en-US"/>
           </a:p>
@@ -1939,7 +1723,7 @@
           <a:p>
             <a:fld id="{21DDE3A9-9D48-7D40-AF95-520AE186EA5D}" type="datetimeFigureOut">
               <a:rPr lang="en-US" smtClean="0"/>
-              <a:t>11/17/21</a:t>
+              <a:t>11/17/25</a:t>
             </a:fld>
             <a:endParaRPr lang="en-US"/>
           </a:p>
@@ -2137,7 +1921,7 @@
           <a:p>
             <a:fld id="{21DDE3A9-9D48-7D40-AF95-520AE186EA5D}" type="datetimeFigureOut">
               <a:rPr lang="en-US" smtClean="0"/>
-              <a:t>11/17/21</a:t>
+              <a:t>11/17/25</a:t>
             </a:fld>
             <a:endParaRPr lang="en-US"/>
           </a:p>
@@ -2412,7 +2196,7 @@
           <a:p>
             <a:fld id="{21DDE3A9-9D48-7D40-AF95-520AE186EA5D}" type="datetimeFigureOut">
               <a:rPr lang="en-US" smtClean="0"/>
-              <a:t>11/17/21</a:t>
+              <a:t>11/17/25</a:t>
             </a:fld>
             <a:endParaRPr lang="en-US"/>
           </a:p>
@@ -2677,7 +2461,7 @@
           <a:p>
             <a:fld id="{21DDE3A9-9D48-7D40-AF95-520AE186EA5D}" type="datetimeFigureOut">
               <a:rPr lang="en-US" smtClean="0"/>
-              <a:t>11/17/21</a:t>
+              <a:t>11/17/25</a:t>
             </a:fld>
             <a:endParaRPr lang="en-US"/>
           </a:p>
@@ -3089,7 +2873,7 @@
           <a:p>
             <a:fld id="{21DDE3A9-9D48-7D40-AF95-520AE186EA5D}" type="datetimeFigureOut">
               <a:rPr lang="en-US" smtClean="0"/>
-              <a:t>11/17/21</a:t>
+              <a:t>11/17/25</a:t>
             </a:fld>
             <a:endParaRPr lang="en-US"/>
           </a:p>
@@ -3230,7 +3014,7 @@
           <a:p>
             <a:fld id="{21DDE3A9-9D48-7D40-AF95-520AE186EA5D}" type="datetimeFigureOut">
               <a:rPr lang="en-US" smtClean="0"/>
-              <a:t>11/17/21</a:t>
+              <a:t>11/17/25</a:t>
             </a:fld>
             <a:endParaRPr lang="en-US"/>
           </a:p>
@@ -3343,7 +3127,7 @@
           <a:p>
             <a:fld id="{21DDE3A9-9D48-7D40-AF95-520AE186EA5D}" type="datetimeFigureOut">
               <a:rPr lang="en-US" smtClean="0"/>
-              <a:t>11/17/21</a:t>
+              <a:t>11/17/25</a:t>
             </a:fld>
             <a:endParaRPr lang="en-US"/>
           </a:p>
@@ -3654,7 +3438,7 @@
           <a:p>
             <a:fld id="{21DDE3A9-9D48-7D40-AF95-520AE186EA5D}" type="datetimeFigureOut">
               <a:rPr lang="en-US" smtClean="0"/>
-              <a:t>11/17/21</a:t>
+              <a:t>11/17/25</a:t>
             </a:fld>
             <a:endParaRPr lang="en-US"/>
           </a:p>
@@ -3942,7 +3726,7 @@
           <a:p>
             <a:fld id="{21DDE3A9-9D48-7D40-AF95-520AE186EA5D}" type="datetimeFigureOut">
               <a:rPr lang="en-US" smtClean="0"/>
-              <a:t>11/17/21</a:t>
+              <a:t>11/17/25</a:t>
             </a:fld>
             <a:endParaRPr lang="en-US"/>
           </a:p>
@@ -4183,7 +3967,7 @@
           <a:p>
             <a:fld id="{21DDE3A9-9D48-7D40-AF95-520AE186EA5D}" type="datetimeFigureOut">
               <a:rPr lang="en-US" smtClean="0"/>
-              <a:t>11/17/21</a:t>
+              <a:t>11/17/25</a:t>
             </a:fld>
             <a:endParaRPr lang="en-US"/>
           </a:p>
@@ -4652,7 +4436,7 @@
                 <a:latin typeface="Avenir Book" panose="02000503020000020003" pitchFamily="2" charset="0"/>
                 <a:cs typeface="Avenir"/>
               </a:rPr>
-              <a:t>Practical session 20</a:t>
+              <a:t>Class 20</a:t>
             </a:r>
             <a:r>
               <a:rPr lang="en-US" sz="4800" dirty="0">
@@ -4683,115 +4467,6 @@
     <p:extLst>
       <p:ext uri="{BB962C8B-B14F-4D97-AF65-F5344CB8AC3E}">
         <p14:creationId xmlns:p14="http://schemas.microsoft.com/office/powerpoint/2010/main" val="1116647298"/>
-      </p:ext>
-    </p:extLst>
-  </p:cSld>
-  <p:clrMapOvr>
-    <a:masterClrMapping/>
-  </p:clrMapOvr>
-</p:sld>
-</file>
-
-<file path=ppt/slides/slide10.xml><?xml version="1.0" encoding="utf-8"?>
-<p:sld xmlns:a="http://schemas.openxmlformats.org/drawingml/2006/main" xmlns:r="http://schemas.openxmlformats.org/officeDocument/2006/relationships" xmlns:p="http://schemas.openxmlformats.org/presentationml/2006/main">
-  <p:cSld>
-    <p:bg>
-      <p:bgPr>
-        <a:solidFill>
-          <a:schemeClr val="tx1"/>
-        </a:solidFill>
-        <a:effectLst/>
-      </p:bgPr>
-    </p:bg>
-    <p:spTree>
-      <p:nvGrpSpPr>
-        <p:cNvPr id="1" name=""/>
-        <p:cNvGrpSpPr/>
-        <p:nvPr/>
-      </p:nvGrpSpPr>
-      <p:grpSpPr>
-        <a:xfrm>
-          <a:off x="0" y="0"/>
-          <a:ext cx="0" cy="0"/>
-          <a:chOff x="0" y="0"/>
-          <a:chExt cx="0" cy="0"/>
-        </a:xfrm>
-      </p:grpSpPr>
-      <p:sp>
-        <p:nvSpPr>
-          <p:cNvPr id="2" name="Rectangle 2"/>
-          <p:cNvSpPr>
-            <a:spLocks noChangeArrowheads="1"/>
-          </p:cNvSpPr>
-          <p:nvPr/>
-        </p:nvSpPr>
-        <p:spPr bwMode="auto">
-          <a:xfrm>
-            <a:off x="352524" y="2644170"/>
-            <a:ext cx="10896600" cy="1569660"/>
-          </a:xfrm>
-          <a:prstGeom prst="rect">
-            <a:avLst/>
-          </a:prstGeom>
-          <a:noFill/>
-          <a:ln w="9525">
-            <a:noFill/>
-            <a:miter lim="800000"/>
-            <a:headEnd/>
-            <a:tailEnd/>
-          </a:ln>
-          <a:effectLst/>
-        </p:spPr>
-        <p:txBody>
-          <a:bodyPr wrap="square">
-            <a:spAutoFit/>
-          </a:bodyPr>
-          <a:lstStyle/>
-          <a:p>
-            <a:pPr>
-              <a:defRPr/>
-            </a:pPr>
-            <a:r>
-              <a:rPr lang="en-US" sz="4800" b="1" dirty="0">
-                <a:solidFill>
-                  <a:schemeClr val="bg1">
-                    <a:lumMod val="65000"/>
-                  </a:schemeClr>
-                </a:solidFill>
-                <a:latin typeface="Avenir Book" panose="02000503020000020003" pitchFamily="2" charset="0"/>
-                <a:cs typeface="Avenir"/>
-              </a:rPr>
-              <a:t>Practical session 20</a:t>
-            </a:r>
-            <a:r>
-              <a:rPr lang="en-US" sz="4800" dirty="0">
-                <a:solidFill>
-                  <a:schemeClr val="bg1">
-                    <a:lumMod val="65000"/>
-                  </a:schemeClr>
-                </a:solidFill>
-                <a:latin typeface="Avenir Book" panose="02000503020000020003" pitchFamily="2" charset="0"/>
-                <a:cs typeface="Avenir"/>
-              </a:rPr>
-              <a:t>: </a:t>
-            </a:r>
-            <a:r>
-              <a:rPr lang="en-US" sz="4800" dirty="0">
-                <a:solidFill>
-                  <a:srgbClr val="FFFFFF"/>
-                </a:solidFill>
-                <a:latin typeface="Avenir Book" panose="02000503020000020003" pitchFamily="2" charset="0"/>
-                <a:cs typeface="Avenir"/>
-              </a:rPr>
-              <a:t>Introduction to the Protozoa and Protozoa 1</a:t>
-            </a:r>
-          </a:p>
-        </p:txBody>
-      </p:sp>
-    </p:spTree>
-    <p:extLst>
-      <p:ext uri="{BB962C8B-B14F-4D97-AF65-F5344CB8AC3E}">
-        <p14:creationId xmlns:p14="http://schemas.microsoft.com/office/powerpoint/2010/main" val="3799852587"/>
       </p:ext>
     </p:extLst>
   </p:cSld>
@@ -5149,14 +4824,14 @@
           </a:ln>
           <a:extLst>
             <a:ext uri="{909E8E84-426E-40dd-AFC4-6F175D3DCCD1}">
-              <a14:hiddenFill xmlns:a14="http://schemas.microsoft.com/office/drawing/2010/main" xmlns="">
+              <a14:hiddenFill xmlns="" xmlns:a14="http://schemas.microsoft.com/office/drawing/2010/main">
                 <a:solidFill>
                   <a:srgbClr val="FFFFFF"/>
                 </a:solidFill>
               </a14:hiddenFill>
             </a:ext>
             <a:ext uri="{91240B29-F687-4f45-9708-019B960494DF}">
-              <a14:hiddenLine xmlns:a14="http://schemas.microsoft.com/office/drawing/2010/main" xmlns="" w="9525">
+              <a14:hiddenLine xmlns="" xmlns:a14="http://schemas.microsoft.com/office/drawing/2010/main" w="9525">
                 <a:solidFill>
                   <a:srgbClr val="000000"/>
                 </a:solidFill>
@@ -5280,133 +4955,6 @@
           <a:chExt cx="0" cy="0"/>
         </a:xfrm>
       </p:grpSpPr>
-      <p:pic>
-        <p:nvPicPr>
-          <p:cNvPr id="5" name="Picture 4">
-            <a:extLst>
-              <a:ext uri="{FF2B5EF4-FFF2-40B4-BE49-F238E27FC236}">
-                <a16:creationId xmlns:a16="http://schemas.microsoft.com/office/drawing/2014/main" id="{C8F37AE3-B782-4641-8C9A-7A9115E2FD8D}"/>
-              </a:ext>
-            </a:extLst>
-          </p:cNvPr>
-          <p:cNvPicPr>
-            <a:picLocks noChangeAspect="1"/>
-          </p:cNvPicPr>
-          <p:nvPr/>
-        </p:nvPicPr>
-        <p:blipFill rotWithShape="1">
-          <a:blip r:embed="rId3"/>
-          <a:srcRect l="6978" t="6285" r="7095" b="7757"/>
-          <a:stretch/>
-        </p:blipFill>
-        <p:spPr>
-          <a:xfrm>
-            <a:off x="1128713" y="128588"/>
-            <a:ext cx="9929812" cy="6615541"/>
-          </a:xfrm>
-          <a:prstGeom prst="rect">
-            <a:avLst/>
-          </a:prstGeom>
-        </p:spPr>
-      </p:pic>
-      <p:sp>
-        <p:nvSpPr>
-          <p:cNvPr id="6" name="Rectangle 5">
-            <a:extLst>
-              <a:ext uri="{FF2B5EF4-FFF2-40B4-BE49-F238E27FC236}">
-                <a16:creationId xmlns:a16="http://schemas.microsoft.com/office/drawing/2014/main" id="{D12FECFF-B1D2-5948-8471-EB955F0A6AD3}"/>
-              </a:ext>
-            </a:extLst>
-          </p:cNvPr>
-          <p:cNvSpPr>
-            <a:spLocks noChangeArrowheads="1"/>
-          </p:cNvSpPr>
-          <p:nvPr/>
-        </p:nvSpPr>
-        <p:spPr bwMode="auto">
-          <a:xfrm>
-            <a:off x="3247971" y="477948"/>
-            <a:ext cx="5691295" cy="630942"/>
-          </a:xfrm>
-          <a:prstGeom prst="rect">
-            <a:avLst/>
-          </a:prstGeom>
-          <a:noFill/>
-          <a:ln w="9525">
-            <a:noFill/>
-            <a:miter lim="800000"/>
-            <a:headEnd/>
-            <a:tailEnd/>
-          </a:ln>
-          <a:effectLst/>
-        </p:spPr>
-        <p:txBody>
-          <a:bodyPr wrap="square">
-            <a:spAutoFit/>
-          </a:bodyPr>
-          <a:lstStyle/>
-          <a:p>
-            <a:pPr algn="ctr">
-              <a:defRPr/>
-            </a:pPr>
-            <a:r>
-              <a:rPr lang="en-US" sz="3500" b="1" dirty="0">
-                <a:latin typeface="Avenir"/>
-                <a:cs typeface="Avenir"/>
-              </a:rPr>
-              <a:t>Q1. </a:t>
-            </a:r>
-            <a:r>
-              <a:rPr lang="en-US" sz="3500" b="1" dirty="0" err="1">
-                <a:latin typeface="Avenir"/>
-                <a:cs typeface="Avenir"/>
-              </a:rPr>
-              <a:t>trophs</a:t>
-            </a:r>
-            <a:r>
-              <a:rPr lang="en-US" sz="3500" b="1" dirty="0">
-                <a:latin typeface="Avenir"/>
-                <a:cs typeface="Avenir"/>
-              </a:rPr>
-              <a:t> and cysts</a:t>
-            </a:r>
-            <a:endParaRPr lang="en-US" sz="3500" b="1" i="1" dirty="0">
-              <a:latin typeface="Avenir"/>
-              <a:cs typeface="Avenir"/>
-            </a:endParaRPr>
-          </a:p>
-        </p:txBody>
-      </p:sp>
-    </p:spTree>
-    <p:extLst>
-      <p:ext uri="{BB962C8B-B14F-4D97-AF65-F5344CB8AC3E}">
-        <p14:creationId xmlns:p14="http://schemas.microsoft.com/office/powerpoint/2010/main" val="1022979280"/>
-      </p:ext>
-    </p:extLst>
-  </p:cSld>
-  <p:clrMapOvr>
-    <a:masterClrMapping/>
-  </p:clrMapOvr>
-</p:sld>
-</file>
-
-<file path=ppt/slides/slide4.xml><?xml version="1.0" encoding="utf-8"?>
-<p:sld xmlns:a="http://schemas.openxmlformats.org/drawingml/2006/main" xmlns:r="http://schemas.openxmlformats.org/officeDocument/2006/relationships" xmlns:p="http://schemas.openxmlformats.org/presentationml/2006/main">
-  <p:cSld>
-    <p:spTree>
-      <p:nvGrpSpPr>
-        <p:cNvPr id="1" name=""/>
-        <p:cNvGrpSpPr/>
-        <p:nvPr/>
-      </p:nvGrpSpPr>
-      <p:grpSpPr>
-        <a:xfrm>
-          <a:off x="0" y="0"/>
-          <a:ext cx="0" cy="0"/>
-          <a:chOff x="0" y="0"/>
-          <a:chExt cx="0" cy="0"/>
-        </a:xfrm>
-      </p:grpSpPr>
       <p:sp>
         <p:nvSpPr>
           <p:cNvPr id="3" name="Rectangle 2"/>
@@ -5494,7 +5042,7 @@
 </p:sld>
 </file>
 
-<file path=ppt/slides/slide5.xml><?xml version="1.0" encoding="utf-8"?>
+<file path=ppt/slides/slide4.xml><?xml version="1.0" encoding="utf-8"?>
 <p:sld xmlns:a="http://schemas.openxmlformats.org/drawingml/2006/main" xmlns:r="http://schemas.openxmlformats.org/officeDocument/2006/relationships" xmlns:p="http://schemas.openxmlformats.org/presentationml/2006/main">
   <p:cSld>
     <p:spTree>
@@ -5604,7 +5152,7 @@
 </p:sld>
 </file>
 
-<file path=ppt/slides/slide6.xml><?xml version="1.0" encoding="utf-8"?>
+<file path=ppt/slides/slide5.xml><?xml version="1.0" encoding="utf-8"?>
 <p:sld xmlns:a="http://schemas.openxmlformats.org/drawingml/2006/main" xmlns:r="http://schemas.openxmlformats.org/officeDocument/2006/relationships" xmlns:p="http://schemas.openxmlformats.org/presentationml/2006/main">
   <p:cSld>
     <p:spTree>
@@ -5714,120 +5262,7 @@
 </p:sld>
 </file>
 
-<file path=ppt/slides/slide7.xml><?xml version="1.0" encoding="utf-8"?>
-<p:sld xmlns:a="http://schemas.openxmlformats.org/drawingml/2006/main" xmlns:r="http://schemas.openxmlformats.org/officeDocument/2006/relationships" xmlns:p="http://schemas.openxmlformats.org/presentationml/2006/main">
-  <p:cSld>
-    <p:spTree>
-      <p:nvGrpSpPr>
-        <p:cNvPr id="1" name=""/>
-        <p:cNvGrpSpPr/>
-        <p:nvPr/>
-      </p:nvGrpSpPr>
-      <p:grpSpPr>
-        <a:xfrm>
-          <a:off x="0" y="0"/>
-          <a:ext cx="0" cy="0"/>
-          <a:chOff x="0" y="0"/>
-          <a:chExt cx="0" cy="0"/>
-        </a:xfrm>
-      </p:grpSpPr>
-      <p:pic>
-        <p:nvPicPr>
-          <p:cNvPr id="5" name="Picture 4">
-            <a:extLst>
-              <a:ext uri="{FF2B5EF4-FFF2-40B4-BE49-F238E27FC236}">
-                <a16:creationId xmlns:a16="http://schemas.microsoft.com/office/drawing/2014/main" id="{C8F37AE3-B782-4641-8C9A-7A9115E2FD8D}"/>
-              </a:ext>
-            </a:extLst>
-          </p:cNvPr>
-          <p:cNvPicPr>
-            <a:picLocks noChangeAspect="1"/>
-          </p:cNvPicPr>
-          <p:nvPr/>
-        </p:nvPicPr>
-        <p:blipFill rotWithShape="1">
-          <a:blip r:embed="rId3"/>
-          <a:srcRect l="6978" t="6285" r="7095" b="7757"/>
-          <a:stretch/>
-        </p:blipFill>
-        <p:spPr>
-          <a:xfrm>
-            <a:off x="1128713" y="128588"/>
-            <a:ext cx="9929812" cy="6615541"/>
-          </a:xfrm>
-          <a:prstGeom prst="rect">
-            <a:avLst/>
-          </a:prstGeom>
-        </p:spPr>
-      </p:pic>
-      <p:sp>
-        <p:nvSpPr>
-          <p:cNvPr id="6" name="Rectangle 5">
-            <a:extLst>
-              <a:ext uri="{FF2B5EF4-FFF2-40B4-BE49-F238E27FC236}">
-                <a16:creationId xmlns:a16="http://schemas.microsoft.com/office/drawing/2014/main" id="{D12FECFF-B1D2-5948-8471-EB955F0A6AD3}"/>
-              </a:ext>
-            </a:extLst>
-          </p:cNvPr>
-          <p:cNvSpPr>
-            <a:spLocks noChangeArrowheads="1"/>
-          </p:cNvSpPr>
-          <p:nvPr/>
-        </p:nvSpPr>
-        <p:spPr bwMode="auto">
-          <a:xfrm>
-            <a:off x="2877590" y="462181"/>
-            <a:ext cx="6432057" cy="630942"/>
-          </a:xfrm>
-          <a:prstGeom prst="rect">
-            <a:avLst/>
-          </a:prstGeom>
-          <a:noFill/>
-          <a:ln w="9525">
-            <a:noFill/>
-            <a:miter lim="800000"/>
-            <a:headEnd/>
-            <a:tailEnd/>
-          </a:ln>
-          <a:effectLst/>
-        </p:spPr>
-        <p:txBody>
-          <a:bodyPr wrap="square">
-            <a:spAutoFit/>
-          </a:bodyPr>
-          <a:lstStyle/>
-          <a:p>
-            <a:pPr algn="ctr">
-              <a:defRPr/>
-            </a:pPr>
-            <a:r>
-              <a:rPr lang="en-US" sz="3500" b="1" dirty="0">
-                <a:latin typeface="Avenir"/>
-                <a:cs typeface="Avenir"/>
-              </a:rPr>
-              <a:t>Q2. African sleeping sickness</a:t>
-            </a:r>
-            <a:endParaRPr lang="en-US" sz="3500" b="1" i="1" dirty="0">
-              <a:latin typeface="Avenir"/>
-              <a:cs typeface="Avenir"/>
-            </a:endParaRPr>
-          </a:p>
-        </p:txBody>
-      </p:sp>
-    </p:spTree>
-    <p:extLst>
-      <p:ext uri="{BB962C8B-B14F-4D97-AF65-F5344CB8AC3E}">
-        <p14:creationId xmlns:p14="http://schemas.microsoft.com/office/powerpoint/2010/main" val="2794195699"/>
-      </p:ext>
-    </p:extLst>
-  </p:cSld>
-  <p:clrMapOvr>
-    <a:masterClrMapping/>
-  </p:clrMapOvr>
-</p:sld>
-</file>
-
-<file path=ppt/slides/slide8.xml><?xml version="1.0" encoding="utf-8"?>
+<file path=ppt/slides/slide6.xml><?xml version="1.0" encoding="utf-8"?>
 <p:sld xmlns:a="http://schemas.openxmlformats.org/drawingml/2006/main" xmlns:r="http://schemas.openxmlformats.org/officeDocument/2006/relationships" xmlns:p="http://schemas.openxmlformats.org/presentationml/2006/main">
   <p:cSld>
     <p:spTree>
@@ -5931,7 +5366,7 @@
 </p:sld>
 </file>
 
-<file path=ppt/slides/slide9.xml><?xml version="1.0" encoding="utf-8"?>
+<file path=ppt/slides/slide7.xml><?xml version="1.0" encoding="utf-8"?>
 <p:sld xmlns:a="http://schemas.openxmlformats.org/drawingml/2006/main" xmlns:r="http://schemas.openxmlformats.org/officeDocument/2006/relationships" xmlns:p="http://schemas.openxmlformats.org/presentationml/2006/main">
   <p:cSld>
     <p:spTree>
@@ -6032,6 +5467,115 @@
     <p:extLst>
       <p:ext uri="{BB962C8B-B14F-4D97-AF65-F5344CB8AC3E}">
         <p14:creationId xmlns:p14="http://schemas.microsoft.com/office/powerpoint/2010/main" val="1505391588"/>
+      </p:ext>
+    </p:extLst>
+  </p:cSld>
+  <p:clrMapOvr>
+    <a:masterClrMapping/>
+  </p:clrMapOvr>
+</p:sld>
+</file>
+
+<file path=ppt/slides/slide8.xml><?xml version="1.0" encoding="utf-8"?>
+<p:sld xmlns:a="http://schemas.openxmlformats.org/drawingml/2006/main" xmlns:r="http://schemas.openxmlformats.org/officeDocument/2006/relationships" xmlns:p="http://schemas.openxmlformats.org/presentationml/2006/main">
+  <p:cSld>
+    <p:bg>
+      <p:bgPr>
+        <a:solidFill>
+          <a:schemeClr val="tx1"/>
+        </a:solidFill>
+        <a:effectLst/>
+      </p:bgPr>
+    </p:bg>
+    <p:spTree>
+      <p:nvGrpSpPr>
+        <p:cNvPr id="1" name=""/>
+        <p:cNvGrpSpPr/>
+        <p:nvPr/>
+      </p:nvGrpSpPr>
+      <p:grpSpPr>
+        <a:xfrm>
+          <a:off x="0" y="0"/>
+          <a:ext cx="0" cy="0"/>
+          <a:chOff x="0" y="0"/>
+          <a:chExt cx="0" cy="0"/>
+        </a:xfrm>
+      </p:grpSpPr>
+      <p:sp>
+        <p:nvSpPr>
+          <p:cNvPr id="2" name="Rectangle 2"/>
+          <p:cNvSpPr>
+            <a:spLocks noChangeArrowheads="1"/>
+          </p:cNvSpPr>
+          <p:nvPr/>
+        </p:nvSpPr>
+        <p:spPr bwMode="auto">
+          <a:xfrm>
+            <a:off x="352524" y="2644170"/>
+            <a:ext cx="10896600" cy="1569660"/>
+          </a:xfrm>
+          <a:prstGeom prst="rect">
+            <a:avLst/>
+          </a:prstGeom>
+          <a:noFill/>
+          <a:ln w="9525">
+            <a:noFill/>
+            <a:miter lim="800000"/>
+            <a:headEnd/>
+            <a:tailEnd/>
+          </a:ln>
+          <a:effectLst/>
+        </p:spPr>
+        <p:txBody>
+          <a:bodyPr wrap="square">
+            <a:spAutoFit/>
+          </a:bodyPr>
+          <a:lstStyle/>
+          <a:p>
+            <a:pPr>
+              <a:defRPr/>
+            </a:pPr>
+            <a:r>
+              <a:rPr lang="en-US" sz="4800" b="1" dirty="0">
+                <a:solidFill>
+                  <a:schemeClr val="bg1">
+                    <a:lumMod val="65000"/>
+                  </a:schemeClr>
+                </a:solidFill>
+                <a:latin typeface="Avenir Book" panose="02000503020000020003" pitchFamily="2" charset="0"/>
+                <a:cs typeface="Avenir"/>
+              </a:rPr>
+              <a:t>Class 20</a:t>
+            </a:r>
+            <a:r>
+              <a:rPr lang="en-US" sz="4800" dirty="0">
+                <a:solidFill>
+                  <a:schemeClr val="bg1">
+                    <a:lumMod val="65000"/>
+                  </a:schemeClr>
+                </a:solidFill>
+                <a:latin typeface="Avenir Book" panose="02000503020000020003" pitchFamily="2" charset="0"/>
+                <a:cs typeface="Avenir"/>
+              </a:rPr>
+              <a:t>: </a:t>
+            </a:r>
+            <a:r>
+              <a:rPr lang="en-US" sz="4800" dirty="0">
+                <a:solidFill>
+                  <a:srgbClr val="FFFFFF"/>
+                </a:solidFill>
+                <a:latin typeface="Avenir Book" panose="02000503020000020003" pitchFamily="2" charset="0"/>
+                <a:cs typeface="Avenir"/>
+              </a:rPr>
+              <a:t>Introduction to the Protozoa and Protozoa 1</a:t>
+            </a:r>
+          </a:p>
+        </p:txBody>
+      </p:sp>
+    </p:spTree>
+    <p:extLst>
+      <p:ext uri="{BB962C8B-B14F-4D97-AF65-F5344CB8AC3E}">
+        <p14:creationId xmlns:p14="http://schemas.microsoft.com/office/powerpoint/2010/main" val="3799852587"/>
       </p:ext>
     </p:extLst>
   </p:cSld>

</xml_diff>